<commit_message>
Lezione 12: GuardDuty, accorgersi degli attacchi (dispensa e slide)
</commit_message>
<xml_diff>
--- a/slide/slide-11-efs-backup.pptx
+++ b/slide/slide-11-efs-backup.pptx
@@ -688,7 +688,7 @@
           <a:p>
             <a:r>
               <a:rPr lang="en-US" dirty="0"/>
-              <a:t>Riassumendo. Il materiale di studio è la dispensa 11, con storage.tf e backup.tf spiegati blocco per blocco. Con questa lezione facoltativa il percorso del corso è completo; resta l'appendice, con gli argomenti avanzati di IAM e di audit.</a:t>
+              <a:t>Riassumendo. Il materiale di studio è la dispensa 11, con storage.tf e backup.tf spiegati blocco per blocco. La prossima lezione accende GuardDuty, per accorgersi degli attacchi; poi resta l'appendice.</a:t>
             </a:r>
             <a:endParaRPr lang="en-US" dirty="0"/>
           </a:p>
@@ -4543,7 +4543,7 @@
                 <a:ea typeface="Calibri" pitchFamily="34" charset="-122"/>
                 <a:cs typeface="Calibri" pitchFamily="34" charset="-120"/>
               </a:rPr>
-              <a:t>Appendice: IAM avanzato e audit</a:t>
+              <a:t>GuardDuty: accorgersi degli attacchi</a:t>
             </a:r>
             <a:endParaRPr lang="en-US" sz="1400" dirty="0"/>
           </a:p>

</xml_diff>

<commit_message>
Lezione 12: CloudTrail, chi ha fatto cosa; GuardDuty diventa la 13; appendice alleggerita
</commit_message>
<xml_diff>
--- a/slide/slide-11-efs-backup.pptx
+++ b/slide/slide-11-efs-backup.pptx
@@ -688,7 +688,7 @@
           <a:p>
             <a:r>
               <a:rPr lang="en-US" dirty="0"/>
-              <a:t>Riassumendo. Il materiale di studio è la dispensa 11, con storage.tf e backup.tf spiegati blocco per blocco. La prossima lezione accende GuardDuty, per accorgersi degli attacchi; poi resta l'appendice.</a:t>
+              <a:t>Riassumendo. Il materiale di studio è la dispensa 11, con storage.tf e backup.tf spiegati blocco per blocco. La prossima lezione è CloudTrail, il registro di chi ha fatto cosa nell'account; poi GuardDuty, per accorgersi degli attacchi.</a:t>
             </a:r>
             <a:endParaRPr lang="en-US" dirty="0"/>
           </a:p>
@@ -4543,7 +4543,7 @@
                 <a:ea typeface="Calibri" pitchFamily="34" charset="-122"/>
                 <a:cs typeface="Calibri" pitchFamily="34" charset="-120"/>
               </a:rPr>
-              <a:t>GuardDuty: accorgersi degli attacchi</a:t>
+              <a:t>CloudTrail: chi ha fatto cosa</a:t>
             </a:r>
             <a:endParaRPr lang="en-US" sz="1400" dirty="0"/>
           </a:p>

</xml_diff>